<commit_message>
Fix pitch deck layout, remove dashes
</commit_message>
<xml_diff>
--- a/docs/Rail_Saarthi_Pitch.pptx
+++ b/docs/Rail_Saarthi_Pitch.pptx
@@ -3263,7 +3263,7 @@
                 </a:solidFill>
                 <a:latin typeface="Calibri"/>
               </a:rPr>
-              <a:t>Multi-agent AI that keeps trains on time — in real time.</a:t>
+              <a:t>Multi-agent AI that keeps trains on time, in real time.</a:t>
             </a:r>
           </a:p>
         </p:txBody>
@@ -3586,7 +3586,7 @@
                 </a:solidFill>
                 <a:latin typeface="Calibri"/>
               </a:rPr>
-              <a:t>India's railways are falling behind — </a:t>
+              <a:t>India's railways are falling behind, </a:t>
             </a:r>
             <a:r>
               <a:rPr sz="4000" b="1" i="0">
@@ -3656,8 +3656,8 @@
         </p:nvSpPr>
         <p:spPr>
           <a:xfrm>
-            <a:off x="1005840" y="3063240"/>
-            <a:ext cx="4754880" cy="457200"/>
+            <a:off x="1005840" y="3108960"/>
+            <a:ext cx="4937760" cy="365760"/>
           </a:xfrm>
           <a:prstGeom prst="rect">
             <a:avLst/>
@@ -3679,13 +3679,13 @@
               </a:spcAft>
             </a:pPr>
             <a:r>
-              <a:rPr sz="1300" b="1" i="0" spc="200">
+              <a:rPr sz="1300" b="1" i="0" spc="150">
                 <a:solidFill>
                   <a:srgbClr val="9AA7BD"/>
                 </a:solidFill>
                 <a:latin typeface="Calibri"/>
               </a:rPr>
-              <a:t>ON-TIME PERFORMANCE</a:t>
+              <a:t>ON-TIME PERFORMANCE, KEY ROUTES</a:t>
             </a:r>
           </a:p>
         </p:txBody>
@@ -3698,8 +3698,8 @@
         </p:nvSpPr>
         <p:spPr>
           <a:xfrm>
-            <a:off x="1005840" y="3520440"/>
-            <a:ext cx="4937760" cy="1371600"/>
+            <a:off x="1005840" y="3657600"/>
+            <a:ext cx="4937760" cy="640080"/>
           </a:xfrm>
           <a:prstGeom prst="rect">
             <a:avLst/>
@@ -3721,7 +3721,7 @@
               </a:spcAft>
             </a:pPr>
             <a:r>
-              <a:rPr sz="4600" b="1" i="0">
+              <a:rPr sz="3200" b="1" i="0">
                 <a:solidFill>
                   <a:srgbClr val="9AA7BD"/>
                 </a:solidFill>
@@ -3730,22 +3730,13 @@
               <a:t>94.2%</a:t>
             </a:r>
             <a:r>
-              <a:rPr sz="4000" b="1" i="0">
-                <a:solidFill>
-                  <a:srgbClr val="FF9E1B"/>
-                </a:solidFill>
-                <a:latin typeface="Calibri"/>
-              </a:rPr>
-              <a:t>  →  </a:t>
-            </a:r>
-            <a:r>
-              <a:rPr sz="5800" b="1" i="0">
-                <a:solidFill>
-                  <a:srgbClr val="FF9E1B"/>
-                </a:solidFill>
-                <a:latin typeface="Calibri"/>
-              </a:rPr>
-              <a:t>73.6%</a:t>
+              <a:rPr sz="1400" b="0" i="0">
+                <a:solidFill>
+                  <a:srgbClr val="9AA7BD"/>
+                </a:solidFill>
+                <a:latin typeface="Calibri"/>
+              </a:rPr>
+              <a:t>   in 2020</a:t>
             </a:r>
           </a:p>
         </p:txBody>
@@ -3758,8 +3749,8 @@
         </p:nvSpPr>
         <p:spPr>
           <a:xfrm>
-            <a:off x="1005840" y="5029200"/>
-            <a:ext cx="4754880" cy="548640"/>
+            <a:off x="1005840" y="4297680"/>
+            <a:ext cx="4937760" cy="914400"/>
           </a:xfrm>
           <a:prstGeom prst="rect">
             <a:avLst/>
@@ -3781,20 +3772,71 @@
               </a:spcAft>
             </a:pPr>
             <a:r>
+              <a:rPr sz="5400" b="1" i="0">
+                <a:solidFill>
+                  <a:srgbClr val="FF9E1B"/>
+                </a:solidFill>
+                <a:latin typeface="Calibri"/>
+              </a:rPr>
+              <a:t>73.6%</a:t>
+            </a:r>
+            <a:r>
               <a:rPr sz="1400" b="0" i="0">
                 <a:solidFill>
                   <a:srgbClr val="9AA7BD"/>
                 </a:solidFill>
                 <a:latin typeface="Calibri"/>
               </a:rPr>
-              <a:t>Punctuality on key routes, 2020 → 2023</a:t>
-            </a:r>
-          </a:p>
-        </p:txBody>
-      </p:sp>
-      <p:sp>
-        <p:nvSpPr>
-          <p:cNvPr id="10" name="Rounded Rectangle 9"/>
+              <a:t>   by 2023</a:t>
+            </a:r>
+          </a:p>
+        </p:txBody>
+      </p:sp>
+      <p:sp>
+        <p:nvSpPr>
+          <p:cNvPr id="10" name="TextBox 9"/>
+          <p:cNvSpPr txBox="1"/>
+          <p:nvPr/>
+        </p:nvSpPr>
+        <p:spPr>
+          <a:xfrm>
+            <a:off x="1005840" y="5230368"/>
+            <a:ext cx="4937760" cy="365760"/>
+          </a:xfrm>
+          <a:prstGeom prst="rect">
+            <a:avLst/>
+          </a:prstGeom>
+          <a:noFill/>
+        </p:spPr>
+        <p:txBody>
+          <a:bodyPr wrap="square" anchor="t" lIns="0" rIns="0" tIns="0" bIns="0">
+            <a:spAutoFit/>
+          </a:bodyPr>
+          <a:lstStyle/>
+          <a:p>
+            <a:pPr algn="l">
+              <a:spcBef>
+                <a:spcPts val="0"/>
+              </a:spcBef>
+              <a:spcAft>
+                <a:spcPts val="0"/>
+              </a:spcAft>
+            </a:pPr>
+            <a:r>
+              <a:rPr sz="1300" b="0" i="1">
+                <a:solidFill>
+                  <a:srgbClr val="9AA7BD"/>
+                </a:solidFill>
+                <a:latin typeface="Calibri"/>
+              </a:rPr>
+              <a:t>A 20.6 point fall in just three years.</a:t>
+            </a:r>
+          </a:p>
+        </p:txBody>
+      </p:sp>
+      <p:sp>
+        <p:nvSpPr>
+          <p:cNvPr id="11" name="Rounded Rectangle 10"/>
           <p:cNvSpPr/>
           <p:nvPr/>
         </p:nvSpPr>
@@ -3842,7 +3884,7 @@
       </p:sp>
       <p:sp>
         <p:nvSpPr>
-          <p:cNvPr id="11" name="TextBox 10"/>
+          <p:cNvPr id="12" name="TextBox 11"/>
           <p:cNvSpPr txBox="1"/>
           <p:nvPr/>
         </p:nvSpPr>
@@ -3884,7 +3926,7 @@
       </p:sp>
       <p:sp>
         <p:nvSpPr>
-          <p:cNvPr id="12" name="TextBox 11"/>
+          <p:cNvPr id="13" name="TextBox 12"/>
           <p:cNvSpPr txBox="1"/>
           <p:nvPr/>
         </p:nvSpPr>
@@ -3929,7 +3971,7 @@
       </p:sp>
       <p:sp>
         <p:nvSpPr>
-          <p:cNvPr id="13" name="Rounded Rectangle 12"/>
+          <p:cNvPr id="14" name="Rounded Rectangle 13"/>
           <p:cNvSpPr/>
           <p:nvPr/>
         </p:nvSpPr>
@@ -3977,7 +4019,7 @@
       </p:sp>
       <p:sp>
         <p:nvSpPr>
-          <p:cNvPr id="14" name="TextBox 13"/>
+          <p:cNvPr id="15" name="TextBox 14"/>
           <p:cNvSpPr txBox="1"/>
           <p:nvPr/>
         </p:nvSpPr>
@@ -4019,7 +4061,7 @@
       </p:sp>
       <p:sp>
         <p:nvSpPr>
-          <p:cNvPr id="15" name="TextBox 14"/>
+          <p:cNvPr id="16" name="TextBox 15"/>
           <p:cNvSpPr txBox="1"/>
           <p:nvPr/>
         </p:nvSpPr>
@@ -4064,7 +4106,7 @@
       </p:sp>
       <p:sp>
         <p:nvSpPr>
-          <p:cNvPr id="16" name="Rounded Rectangle 15"/>
+          <p:cNvPr id="17" name="Rounded Rectangle 16"/>
           <p:cNvSpPr/>
           <p:nvPr/>
         </p:nvSpPr>
@@ -4112,7 +4154,7 @@
       </p:sp>
       <p:sp>
         <p:nvSpPr>
-          <p:cNvPr id="17" name="TextBox 16"/>
+          <p:cNvPr id="18" name="TextBox 17"/>
           <p:cNvSpPr txBox="1"/>
           <p:nvPr/>
         </p:nvSpPr>
@@ -4154,7 +4196,7 @@
       </p:sp>
       <p:sp>
         <p:nvSpPr>
-          <p:cNvPr id="18" name="TextBox 17"/>
+          <p:cNvPr id="19" name="TextBox 18"/>
           <p:cNvSpPr txBox="1"/>
           <p:nvPr/>
         </p:nvSpPr>
@@ -4199,7 +4241,7 @@
       </p:sp>
       <p:sp>
         <p:nvSpPr>
-          <p:cNvPr id="19" name="TextBox 18"/>
+          <p:cNvPr id="20" name="TextBox 19"/>
           <p:cNvSpPr txBox="1"/>
           <p:nvPr/>
         </p:nvSpPr>
@@ -4241,7 +4283,7 @@
       </p:sp>
       <p:sp>
         <p:nvSpPr>
-          <p:cNvPr id="20" name="TextBox 19"/>
+          <p:cNvPr id="21" name="TextBox 20"/>
           <p:cNvSpPr txBox="1"/>
           <p:nvPr/>
         </p:nvSpPr>
@@ -4645,7 +4687,7 @@
                 </a:solidFill>
                 <a:latin typeface="Calibri"/>
               </a:rPr>
-              <a:t>80% of key routes run over capacity — no slack to absorb a single slip.</a:t>
+              <a:t>80% of key routes run over capacity, with no slack to absorb a single slip.</a:t>
             </a:r>
           </a:p>
         </p:txBody>
@@ -5182,7 +5224,7 @@
                 </a:solidFill>
                 <a:latin typeface="Calibri"/>
               </a:rPr>
-              <a:t>Passengers learn of disruptions late, if at all — no live, trustworthy updates.</a:t>
+              <a:t>Passengers learn of disruptions late, if at all, with no live, trustworthy updates.</a:t>
             </a:r>
           </a:p>
         </p:txBody>
@@ -5316,7 +5358,7 @@
                 </a:solidFill>
                 <a:latin typeface="Calibri"/>
               </a:rPr>
-              <a:t>Freight–passenger conflict</a:t>
+              <a:t>Freight vs passenger conflict</a:t>
             </a:r>
           </a:p>
         </p:txBody>
@@ -5823,7 +5865,7 @@
                 </a:solidFill>
                 <a:latin typeface="Calibri"/>
               </a:rPr>
-              <a:t> — an agentic OS for Indian Railways</a:t>
+              <a:t>: an agentic OS for Indian Railways</a:t>
             </a:r>
           </a:p>
         </p:txBody>
@@ -6002,7 +6044,7 @@
                 </a:solidFill>
                 <a:latin typeface="Calibri"/>
               </a:rPr>
-              <a:t>A multi-agent AI system — Train, Station, Crew, Maintenance and Passenger agents coordinating on a live digital twin.</a:t>
+              <a:t>A multi-agent AI system: Train, Station, Crew, Maintenance and Passenger agents coordinating on a live digital twin.</a:t>
             </a:r>
           </a:p>
         </p:txBody>
@@ -6927,7 +6969,7 @@
                 </a:solidFill>
                 <a:latin typeface="Calibri"/>
               </a:rPr>
-              <a:t>live train positions on the NDLS–DDU line</a:t>
+              <a:t>live train positions on the NDLS to DDU line</a:t>
             </a:r>
           </a:p>
         </p:txBody>
@@ -10382,7 +10424,7 @@
                 </a:solidFill>
                 <a:latin typeface="Calibri"/>
               </a:rPr>
-              <a:t>Simulated results — pilot validation planned.</a:t>
+              <a:t>Simulated results. Pilot validation planned.</a:t>
             </a:r>
           </a:p>
         </p:txBody>

</xml_diff>

<commit_message>
Fix pitch deck layout, remove dashes (#20)
* Fix pitch deck layout, remove dashes

* Drop em dash from code comment
</commit_message>
<xml_diff>
--- a/docs/Rail_Saarthi_Pitch.pptx
+++ b/docs/Rail_Saarthi_Pitch.pptx
@@ -3263,7 +3263,7 @@
                 </a:solidFill>
                 <a:latin typeface="Calibri"/>
               </a:rPr>
-              <a:t>Multi-agent AI that keeps trains on time — in real time.</a:t>
+              <a:t>Multi-agent AI that keeps trains on time, in real time.</a:t>
             </a:r>
           </a:p>
         </p:txBody>
@@ -3586,7 +3586,7 @@
                 </a:solidFill>
                 <a:latin typeface="Calibri"/>
               </a:rPr>
-              <a:t>India's railways are falling behind — </a:t>
+              <a:t>India's railways are falling behind, </a:t>
             </a:r>
             <a:r>
               <a:rPr sz="4000" b="1" i="0">
@@ -3656,8 +3656,8 @@
         </p:nvSpPr>
         <p:spPr>
           <a:xfrm>
-            <a:off x="1005840" y="3063240"/>
-            <a:ext cx="4754880" cy="457200"/>
+            <a:off x="1005840" y="3108960"/>
+            <a:ext cx="4937760" cy="365760"/>
           </a:xfrm>
           <a:prstGeom prst="rect">
             <a:avLst/>
@@ -3679,13 +3679,13 @@
               </a:spcAft>
             </a:pPr>
             <a:r>
-              <a:rPr sz="1300" b="1" i="0" spc="200">
+              <a:rPr sz="1300" b="1" i="0" spc="150">
                 <a:solidFill>
                   <a:srgbClr val="9AA7BD"/>
                 </a:solidFill>
                 <a:latin typeface="Calibri"/>
               </a:rPr>
-              <a:t>ON-TIME PERFORMANCE</a:t>
+              <a:t>ON-TIME PERFORMANCE, KEY ROUTES</a:t>
             </a:r>
           </a:p>
         </p:txBody>
@@ -3698,8 +3698,8 @@
         </p:nvSpPr>
         <p:spPr>
           <a:xfrm>
-            <a:off x="1005840" y="3520440"/>
-            <a:ext cx="4937760" cy="1371600"/>
+            <a:off x="1005840" y="3657600"/>
+            <a:ext cx="4937760" cy="640080"/>
           </a:xfrm>
           <a:prstGeom prst="rect">
             <a:avLst/>
@@ -3721,7 +3721,7 @@
               </a:spcAft>
             </a:pPr>
             <a:r>
-              <a:rPr sz="4600" b="1" i="0">
+              <a:rPr sz="3200" b="1" i="0">
                 <a:solidFill>
                   <a:srgbClr val="9AA7BD"/>
                 </a:solidFill>
@@ -3730,22 +3730,13 @@
               <a:t>94.2%</a:t>
             </a:r>
             <a:r>
-              <a:rPr sz="4000" b="1" i="0">
-                <a:solidFill>
-                  <a:srgbClr val="FF9E1B"/>
-                </a:solidFill>
-                <a:latin typeface="Calibri"/>
-              </a:rPr>
-              <a:t>  →  </a:t>
-            </a:r>
-            <a:r>
-              <a:rPr sz="5800" b="1" i="0">
-                <a:solidFill>
-                  <a:srgbClr val="FF9E1B"/>
-                </a:solidFill>
-                <a:latin typeface="Calibri"/>
-              </a:rPr>
-              <a:t>73.6%</a:t>
+              <a:rPr sz="1400" b="0" i="0">
+                <a:solidFill>
+                  <a:srgbClr val="9AA7BD"/>
+                </a:solidFill>
+                <a:latin typeface="Calibri"/>
+              </a:rPr>
+              <a:t>   in 2020</a:t>
             </a:r>
           </a:p>
         </p:txBody>
@@ -3758,8 +3749,8 @@
         </p:nvSpPr>
         <p:spPr>
           <a:xfrm>
-            <a:off x="1005840" y="5029200"/>
-            <a:ext cx="4754880" cy="548640"/>
+            <a:off x="1005840" y="4297680"/>
+            <a:ext cx="4937760" cy="914400"/>
           </a:xfrm>
           <a:prstGeom prst="rect">
             <a:avLst/>
@@ -3781,20 +3772,71 @@
               </a:spcAft>
             </a:pPr>
             <a:r>
+              <a:rPr sz="5400" b="1" i="0">
+                <a:solidFill>
+                  <a:srgbClr val="FF9E1B"/>
+                </a:solidFill>
+                <a:latin typeface="Calibri"/>
+              </a:rPr>
+              <a:t>73.6%</a:t>
+            </a:r>
+            <a:r>
               <a:rPr sz="1400" b="0" i="0">
                 <a:solidFill>
                   <a:srgbClr val="9AA7BD"/>
                 </a:solidFill>
                 <a:latin typeface="Calibri"/>
               </a:rPr>
-              <a:t>Punctuality on key routes, 2020 → 2023</a:t>
-            </a:r>
-          </a:p>
-        </p:txBody>
-      </p:sp>
-      <p:sp>
-        <p:nvSpPr>
-          <p:cNvPr id="10" name="Rounded Rectangle 9"/>
+              <a:t>   by 2023</a:t>
+            </a:r>
+          </a:p>
+        </p:txBody>
+      </p:sp>
+      <p:sp>
+        <p:nvSpPr>
+          <p:cNvPr id="10" name="TextBox 9"/>
+          <p:cNvSpPr txBox="1"/>
+          <p:nvPr/>
+        </p:nvSpPr>
+        <p:spPr>
+          <a:xfrm>
+            <a:off x="1005840" y="5230368"/>
+            <a:ext cx="4937760" cy="365760"/>
+          </a:xfrm>
+          <a:prstGeom prst="rect">
+            <a:avLst/>
+          </a:prstGeom>
+          <a:noFill/>
+        </p:spPr>
+        <p:txBody>
+          <a:bodyPr wrap="square" anchor="t" lIns="0" rIns="0" tIns="0" bIns="0">
+            <a:spAutoFit/>
+          </a:bodyPr>
+          <a:lstStyle/>
+          <a:p>
+            <a:pPr algn="l">
+              <a:spcBef>
+                <a:spcPts val="0"/>
+              </a:spcBef>
+              <a:spcAft>
+                <a:spcPts val="0"/>
+              </a:spcAft>
+            </a:pPr>
+            <a:r>
+              <a:rPr sz="1300" b="0" i="1">
+                <a:solidFill>
+                  <a:srgbClr val="9AA7BD"/>
+                </a:solidFill>
+                <a:latin typeface="Calibri"/>
+              </a:rPr>
+              <a:t>A 20.6 point fall in just three years.</a:t>
+            </a:r>
+          </a:p>
+        </p:txBody>
+      </p:sp>
+      <p:sp>
+        <p:nvSpPr>
+          <p:cNvPr id="11" name="Rounded Rectangle 10"/>
           <p:cNvSpPr/>
           <p:nvPr/>
         </p:nvSpPr>
@@ -3842,7 +3884,7 @@
       </p:sp>
       <p:sp>
         <p:nvSpPr>
-          <p:cNvPr id="11" name="TextBox 10"/>
+          <p:cNvPr id="12" name="TextBox 11"/>
           <p:cNvSpPr txBox="1"/>
           <p:nvPr/>
         </p:nvSpPr>
@@ -3884,7 +3926,7 @@
       </p:sp>
       <p:sp>
         <p:nvSpPr>
-          <p:cNvPr id="12" name="TextBox 11"/>
+          <p:cNvPr id="13" name="TextBox 12"/>
           <p:cNvSpPr txBox="1"/>
           <p:nvPr/>
         </p:nvSpPr>
@@ -3929,7 +3971,7 @@
       </p:sp>
       <p:sp>
         <p:nvSpPr>
-          <p:cNvPr id="13" name="Rounded Rectangle 12"/>
+          <p:cNvPr id="14" name="Rounded Rectangle 13"/>
           <p:cNvSpPr/>
           <p:nvPr/>
         </p:nvSpPr>
@@ -3977,7 +4019,7 @@
       </p:sp>
       <p:sp>
         <p:nvSpPr>
-          <p:cNvPr id="14" name="TextBox 13"/>
+          <p:cNvPr id="15" name="TextBox 14"/>
           <p:cNvSpPr txBox="1"/>
           <p:nvPr/>
         </p:nvSpPr>
@@ -4019,7 +4061,7 @@
       </p:sp>
       <p:sp>
         <p:nvSpPr>
-          <p:cNvPr id="15" name="TextBox 14"/>
+          <p:cNvPr id="16" name="TextBox 15"/>
           <p:cNvSpPr txBox="1"/>
           <p:nvPr/>
         </p:nvSpPr>
@@ -4064,7 +4106,7 @@
       </p:sp>
       <p:sp>
         <p:nvSpPr>
-          <p:cNvPr id="16" name="Rounded Rectangle 15"/>
+          <p:cNvPr id="17" name="Rounded Rectangle 16"/>
           <p:cNvSpPr/>
           <p:nvPr/>
         </p:nvSpPr>
@@ -4112,7 +4154,7 @@
       </p:sp>
       <p:sp>
         <p:nvSpPr>
-          <p:cNvPr id="17" name="TextBox 16"/>
+          <p:cNvPr id="18" name="TextBox 17"/>
           <p:cNvSpPr txBox="1"/>
           <p:nvPr/>
         </p:nvSpPr>
@@ -4154,7 +4196,7 @@
       </p:sp>
       <p:sp>
         <p:nvSpPr>
-          <p:cNvPr id="18" name="TextBox 17"/>
+          <p:cNvPr id="19" name="TextBox 18"/>
           <p:cNvSpPr txBox="1"/>
           <p:nvPr/>
         </p:nvSpPr>
@@ -4199,7 +4241,7 @@
       </p:sp>
       <p:sp>
         <p:nvSpPr>
-          <p:cNvPr id="19" name="TextBox 18"/>
+          <p:cNvPr id="20" name="TextBox 19"/>
           <p:cNvSpPr txBox="1"/>
           <p:nvPr/>
         </p:nvSpPr>
@@ -4241,7 +4283,7 @@
       </p:sp>
       <p:sp>
         <p:nvSpPr>
-          <p:cNvPr id="20" name="TextBox 19"/>
+          <p:cNvPr id="21" name="TextBox 20"/>
           <p:cNvSpPr txBox="1"/>
           <p:nvPr/>
         </p:nvSpPr>
@@ -4645,7 +4687,7 @@
                 </a:solidFill>
                 <a:latin typeface="Calibri"/>
               </a:rPr>
-              <a:t>80% of key routes run over capacity — no slack to absorb a single slip.</a:t>
+              <a:t>80% of key routes run over capacity, with no slack to absorb a single slip.</a:t>
             </a:r>
           </a:p>
         </p:txBody>
@@ -5182,7 +5224,7 @@
                 </a:solidFill>
                 <a:latin typeface="Calibri"/>
               </a:rPr>
-              <a:t>Passengers learn of disruptions late, if at all — no live, trustworthy updates.</a:t>
+              <a:t>Passengers learn of disruptions late, if at all, with no live, trustworthy updates.</a:t>
             </a:r>
           </a:p>
         </p:txBody>
@@ -5316,7 +5358,7 @@
                 </a:solidFill>
                 <a:latin typeface="Calibri"/>
               </a:rPr>
-              <a:t>Freight–passenger conflict</a:t>
+              <a:t>Freight vs passenger conflict</a:t>
             </a:r>
           </a:p>
         </p:txBody>
@@ -5823,7 +5865,7 @@
                 </a:solidFill>
                 <a:latin typeface="Calibri"/>
               </a:rPr>
-              <a:t> — an agentic OS for Indian Railways</a:t>
+              <a:t>: an agentic OS for Indian Railways</a:t>
             </a:r>
           </a:p>
         </p:txBody>
@@ -6002,7 +6044,7 @@
                 </a:solidFill>
                 <a:latin typeface="Calibri"/>
               </a:rPr>
-              <a:t>A multi-agent AI system — Train, Station, Crew, Maintenance and Passenger agents coordinating on a live digital twin.</a:t>
+              <a:t>A multi-agent AI system: Train, Station, Crew, Maintenance and Passenger agents coordinating on a live digital twin.</a:t>
             </a:r>
           </a:p>
         </p:txBody>
@@ -6927,7 +6969,7 @@
                 </a:solidFill>
                 <a:latin typeface="Calibri"/>
               </a:rPr>
-              <a:t>live train positions on the NDLS–DDU line</a:t>
+              <a:t>live train positions on the NDLS to DDU line</a:t>
             </a:r>
           </a:p>
         </p:txBody>
@@ -10382,7 +10424,7 @@
                 </a:solidFill>
                 <a:latin typeface="Calibri"/>
               </a:rPr>
-              <a:t>Simulated results — pilot validation planned.</a:t>
+              <a:t>Simulated results. Pilot validation planned.</a:t>
             </a:r>
           </a:p>
         </p:txBody>

</xml_diff>